<commit_message>
feat(presentation): embed rich graphics and live screenshots on every single slide of 8-slide deck
</commit_message>
<xml_diff>
--- a/public/Vyapar_2.0_Presentation.pptx
+++ b/public/Vyapar_2.0_Presentation.pptx
@@ -3146,8 +3146,8 @@
         </p:nvSpPr>
         <p:spPr>
           <a:xfrm>
-            <a:off x="731520" y="731520"/>
-            <a:ext cx="5669280" cy="5303520"/>
+            <a:off x="731520" y="640080"/>
+            <a:ext cx="5852160" cy="3291840"/>
           </a:xfrm>
           <a:prstGeom prst="rect">
             <a:avLst/>
@@ -3161,7 +3161,7 @@
           <a:lstStyle/>
           <a:p>
             <a:pPr>
-              <a:defRPr sz="1200" b="1">
+              <a:defRPr sz="1100" b="1">
                 <a:solidFill>
                   <a:srgbClr val="6366F1"/>
                 </a:solidFill>
@@ -3170,6 +3170,22 @@
             </a:pPr>
             <a:r>
               <a:t>ENTERPRISE 2.0 RELEASE</a:t>
+            </a:r>
+          </a:p>
+          <a:p>
+            <a:pPr>
+              <a:spcBef>
+                <a:spcPts val="800"/>
+              </a:spcBef>
+              <a:defRPr sz="4400" b="1">
+                <a:solidFill>
+                  <a:srgbClr val="FFFFFF"/>
+                </a:solidFill>
+                <a:latin typeface="Arial"/>
+              </a:defRPr>
+            </a:pPr>
+            <a:r>
+              <a:t>VYAPAR 2.0</a:t>
             </a:r>
           </a:p>
           <a:p>
@@ -3177,15 +3193,15 @@
               <a:spcBef>
                 <a:spcPts val="1000"/>
               </a:spcBef>
-              <a:defRPr sz="4400" b="1">
-                <a:solidFill>
-                  <a:srgbClr val="FFFFFF"/>
-                </a:solidFill>
-                <a:latin typeface="Arial"/>
-              </a:defRPr>
-            </a:pPr>
-            <a:r>
-              <a:t>VYAPAR 2.0</a:t>
+              <a:defRPr sz="1500">
+                <a:solidFill>
+                  <a:srgbClr val="CBD5E1"/>
+                </a:solidFill>
+                <a:latin typeface="Arial"/>
+              </a:defRPr>
+            </a:pPr>
+            <a:r>
+              <a:t>Smart Accounting, Inventory &amp; Real-Time Delivery Operating System for Modern Indian Merchants.</a:t>
             </a:r>
           </a:p>
           <a:p>
@@ -3193,22 +3209,6 @@
               <a:spcBef>
                 <a:spcPts val="1200"/>
               </a:spcBef>
-              <a:defRPr sz="1600">
-                <a:solidFill>
-                  <a:srgbClr val="CBD5E1"/>
-                </a:solidFill>
-                <a:latin typeface="Arial"/>
-              </a:defRPr>
-            </a:pPr>
-            <a:r>
-              <a:t>Smart Accounting, Inventory &amp; Real-Time Delivery Operating System for Modern Indian Merchants.</a:t>
-            </a:r>
-          </a:p>
-          <a:p>
-            <a:pPr>
-              <a:spcBef>
-                <a:spcPts val="1800"/>
-              </a:spcBef>
               <a:defRPr sz="1100" b="1">
                 <a:solidFill>
                   <a:srgbClr val="06B6D4"/>
@@ -3217,7 +3217,7 @@
               </a:defRPr>
             </a:pPr>
             <a:r>
-              <a:t>⚡ Real-Time GPS Tracking  |  🧾 GST Invoices &amp; POS  |  📦 Barcode Engine  |  📒 Digital Khata</a:t>
+              <a:t>⚡ Real-Time GPS  |  🧾 GST POS  |  📦 Barcodes  |  📒 Digital Khata</a:t>
             </a:r>
           </a:p>
         </p:txBody>
@@ -3230,8 +3230,8 @@
         </p:nvSpPr>
         <p:spPr>
           <a:xfrm>
-            <a:off x="731520" y="3931920"/>
-            <a:ext cx="5303520" cy="2103120"/>
+            <a:off x="731520" y="4114800"/>
+            <a:ext cx="5669280" cy="2103120"/>
           </a:xfrm>
           <a:prstGeom prst="roundRect">
             <a:avLst/>
@@ -3260,7 +3260,7 @@
           </a:fontRef>
         </p:style>
         <p:txBody>
-          <a:bodyPr rtlCol="0" anchor="ctr" lIns="274320" tIns="182880"/>
+          <a:bodyPr rtlCol="0" anchor="ctr" lIns="274320" tIns="164592"/>
           <a:lstStyle/>
           <a:p>
             <a:pPr algn="ctr">
@@ -3357,8 +3357,8 @@
         </p:blipFill>
         <p:spPr>
           <a:xfrm>
-            <a:off x="6400800" y="1005840"/>
-            <a:ext cx="5029200" cy="2806995"/>
+            <a:off x="6675120" y="1005840"/>
+            <a:ext cx="4846320" cy="2704923"/>
           </a:xfrm>
           <a:prstGeom prst="rect">
             <a:avLst/>
@@ -3435,7 +3435,7 @@
         <p:spPr>
           <a:xfrm>
             <a:off x="731520" y="365760"/>
-            <a:ext cx="4114800" cy="365760"/>
+            <a:ext cx="5486400" cy="320040"/>
           </a:xfrm>
           <a:prstGeom prst="rect">
             <a:avLst/>
@@ -3470,8 +3470,8 @@
         </p:nvSpPr>
         <p:spPr>
           <a:xfrm>
-            <a:off x="731520" y="685800"/>
-            <a:ext cx="10515600" cy="731520"/>
+            <a:off x="731520" y="658368"/>
+            <a:ext cx="10515600" cy="640080"/>
           </a:xfrm>
           <a:prstGeom prst="rect">
             <a:avLst/>
@@ -3485,7 +3485,7 @@
           <a:lstStyle/>
           <a:p>
             <a:pPr>
-              <a:defRPr sz="2800" b="1">
+              <a:defRPr sz="2600" b="1">
                 <a:solidFill>
                   <a:srgbClr val="FFFFFF"/>
                 </a:solidFill>
@@ -3506,8 +3506,8 @@
         </p:nvSpPr>
         <p:spPr>
           <a:xfrm>
-            <a:off x="731520" y="1325880"/>
-            <a:ext cx="10515600" cy="457200"/>
+            <a:off x="731520" y="1261872"/>
+            <a:ext cx="10515600" cy="411480"/>
           </a:xfrm>
           <a:prstGeom prst="rect">
             <a:avLst/>
@@ -3521,7 +3521,7 @@
           <a:lstStyle/>
           <a:p>
             <a:pPr>
-              <a:defRPr sz="1300">
+              <a:defRPr sz="1200">
                 <a:solidFill>
                   <a:srgbClr val="94A3B8"/>
                 </a:solidFill>
@@ -3542,8 +3542,8 @@
         </p:nvSpPr>
         <p:spPr>
           <a:xfrm>
-            <a:off x="731520" y="2011680"/>
-            <a:ext cx="5120640" cy="2011680"/>
+            <a:off x="731520" y="1828800"/>
+            <a:ext cx="2926080" cy="2194560"/>
           </a:xfrm>
           <a:prstGeom prst="roundRect">
             <a:avLst/>
@@ -3572,11 +3572,11 @@
           </a:fontRef>
         </p:style>
         <p:txBody>
-          <a:bodyPr rtlCol="0" anchor="ctr" wrap="square" lIns="274320" rIns="274320" tIns="228600" bIns="228600"/>
+          <a:bodyPr rtlCol="0" anchor="ctr" wrap="square" lIns="182880" rIns="182880" tIns="137160" bIns="137160"/>
           <a:lstStyle/>
           <a:p>
             <a:pPr algn="ctr">
-              <a:defRPr sz="1600" b="1">
+              <a:defRPr sz="1300" b="1">
                 <a:solidFill>
                   <a:srgbClr val="FFFFFF"/>
                 </a:solidFill>
@@ -3590,9 +3590,9 @@
           <a:p>
             <a:pPr>
               <a:spcBef>
-                <a:spcPts val="800"/>
+                <a:spcPts val="300"/>
               </a:spcBef>
-              <a:defRPr sz="1200">
+              <a:defRPr sz="1050">
                 <a:solidFill>
                   <a:srgbClr val="CBD5E1"/>
                 </a:solidFill>
@@ -3600,7 +3600,7 @@
               </a:defRPr>
             </a:pPr>
             <a:r>
-              <a:t>Customer credit entries get lost, forgotten, or disputed. Manual phone calls for payment collection feel awkward and waste hours.</a:t>
+              <a:t>Credit entries get lost or disputed. Awkward manual calls for payments waste hours.</a:t>
             </a:r>
           </a:p>
         </p:txBody>
@@ -3613,8 +3613,8 @@
         </p:nvSpPr>
         <p:spPr>
           <a:xfrm>
-            <a:off x="6217920" y="2011680"/>
-            <a:ext cx="5120640" cy="2011680"/>
+            <a:off x="3840480" y="1828800"/>
+            <a:ext cx="2926080" cy="2194560"/>
           </a:xfrm>
           <a:prstGeom prst="roundRect">
             <a:avLst/>
@@ -3643,11 +3643,11 @@
           </a:fontRef>
         </p:style>
         <p:txBody>
-          <a:bodyPr rtlCol="0" anchor="ctr" wrap="square" lIns="274320" rIns="274320" tIns="228600" bIns="228600"/>
+          <a:bodyPr rtlCol="0" anchor="ctr" wrap="square" lIns="182880" rIns="182880" tIns="137160" bIns="137160"/>
           <a:lstStyle/>
           <a:p>
             <a:pPr algn="ctr">
-              <a:defRPr sz="1600" b="1">
+              <a:defRPr sz="1300" b="1">
                 <a:solidFill>
                   <a:srgbClr val="FFFFFF"/>
                 </a:solidFill>
@@ -3655,15 +3655,15 @@
               </a:defRPr>
             </a:pPr>
             <a:r>
-              <a:t>📦  Blind Inventory Control</a:t>
+              <a:t>📦  Blind Inventory</a:t>
             </a:r>
           </a:p>
           <a:p>
             <a:pPr>
               <a:spcBef>
-                <a:spcPts val="800"/>
+                <a:spcPts val="300"/>
               </a:spcBef>
-              <a:defRPr sz="1200">
+              <a:defRPr sz="1050">
                 <a:solidFill>
                   <a:srgbClr val="CBD5E1"/>
                 </a:solidFill>
@@ -3671,7 +3671,7 @@
               </a:defRPr>
             </a:pPr>
             <a:r>
-              <a:t>Popular items run out of stock without notice, while slow-moving items expire unnoticed in the back warehouse.</a:t>
+              <a:t>Stock runs out without notice, while slow items expire unnoticed in warehouses.</a:t>
             </a:r>
           </a:p>
         </p:txBody>
@@ -3684,8 +3684,8 @@
         </p:nvSpPr>
         <p:spPr>
           <a:xfrm>
-            <a:off x="731520" y="4297680"/>
-            <a:ext cx="5120640" cy="2011680"/>
+            <a:off x="731520" y="4206240"/>
+            <a:ext cx="2926080" cy="2194560"/>
           </a:xfrm>
           <a:prstGeom prst="roundRect">
             <a:avLst/>
@@ -3714,11 +3714,11 @@
           </a:fontRef>
         </p:style>
         <p:txBody>
-          <a:bodyPr rtlCol="0" anchor="ctr" wrap="square" lIns="274320" rIns="274320" tIns="228600" bIns="228600"/>
+          <a:bodyPr rtlCol="0" anchor="ctr" wrap="square" lIns="182880" rIns="182880" tIns="137160" bIns="137160"/>
           <a:lstStyle/>
           <a:p>
             <a:pPr algn="ctr">
-              <a:defRPr sz="1600" b="1">
+              <a:defRPr sz="1300" b="1">
                 <a:solidFill>
                   <a:srgbClr val="FFFFFF"/>
                 </a:solidFill>
@@ -3732,9 +3732,9 @@
           <a:p>
             <a:pPr>
               <a:spcBef>
-                <a:spcPts val="800"/>
+                <a:spcPts val="300"/>
               </a:spcBef>
-              <a:defRPr sz="1200">
+              <a:defRPr sz="1050">
                 <a:solidFill>
                   <a:srgbClr val="CBD5E1"/>
                 </a:solidFill>
@@ -3742,7 +3742,7 @@
               </a:defRPr>
             </a:pPr>
             <a:r>
-              <a:t>Typing prices by hand during peak rush hours creates long customer queues, manual calculation mistakes, and missed sales.</a:t>
+              <a:t>Manual pricing during rush hours creates billing errors and customer frustration.</a:t>
             </a:r>
           </a:p>
         </p:txBody>
@@ -3755,8 +3755,8 @@
         </p:nvSpPr>
         <p:spPr>
           <a:xfrm>
-            <a:off x="6217920" y="4297680"/>
-            <a:ext cx="5120640" cy="2011680"/>
+            <a:off x="3840480" y="4206240"/>
+            <a:ext cx="2926080" cy="2194560"/>
           </a:xfrm>
           <a:prstGeom prst="roundRect">
             <a:avLst/>
@@ -3785,11 +3785,11 @@
           </a:fontRef>
         </p:style>
         <p:txBody>
-          <a:bodyPr rtlCol="0" anchor="ctr" wrap="square" lIns="274320" rIns="274320" tIns="228600" bIns="228600"/>
+          <a:bodyPr rtlCol="0" anchor="ctr" wrap="square" lIns="182880" rIns="182880" tIns="137160" bIns="137160"/>
           <a:lstStyle/>
           <a:p>
             <a:pPr algn="ctr">
-              <a:defRPr sz="1600" b="1">
+              <a:defRPr sz="1300" b="1">
                 <a:solidFill>
                   <a:srgbClr val="FFFFFF"/>
                 </a:solidFill>
@@ -3803,9 +3803,9 @@
           <a:p>
             <a:pPr>
               <a:spcBef>
-                <a:spcPts val="800"/>
+                <a:spcPts val="300"/>
               </a:spcBef>
-              <a:defRPr sz="1200">
+              <a:defRPr sz="1050">
                 <a:solidFill>
                   <a:srgbClr val="CBD5E1"/>
                 </a:solidFill>
@@ -3813,11 +3813,35 @@
               </a:defRPr>
             </a:pPr>
             <a:r>
-              <a:t>Customers constantly call asking 'Where is my parcel?' Merchants have no idea where delivery drivers are located.</a:t>
-            </a:r>
-          </a:p>
-        </p:txBody>
-      </p:sp>
+              <a:t>Customers constantly ask 'Where is my order?' Merchants have no way to track drivers.</a:t>
+            </a:r>
+          </a:p>
+        </p:txBody>
+      </p:sp>
+      <p:pic>
+        <p:nvPicPr>
+          <p:cNvPr id="10" name="Picture 9" descr="problem.jpg"/>
+          <p:cNvPicPr>
+            <a:picLocks noChangeAspect="1"/>
+          </p:cNvPicPr>
+          <p:nvPr/>
+        </p:nvPicPr>
+        <p:blipFill>
+          <a:blip r:embed="rId2"/>
+          <a:stretch>
+            <a:fillRect/>
+          </a:stretch>
+        </p:blipFill>
+        <p:spPr>
+          <a:xfrm>
+            <a:off x="7040880" y="1828800"/>
+            <a:ext cx="4389120" cy="2449741"/>
+          </a:xfrm>
+          <a:prstGeom prst="rect">
+            <a:avLst/>
+          </a:prstGeom>
+        </p:spPr>
+      </p:pic>
     </p:spTree>
   </p:cSld>
   <p:clrMapOvr>
@@ -3888,7 +3912,7 @@
         <p:spPr>
           <a:xfrm>
             <a:off x="731520" y="365760"/>
-            <a:ext cx="4114800" cy="365760"/>
+            <a:ext cx="5486400" cy="320040"/>
           </a:xfrm>
           <a:prstGeom prst="rect">
             <a:avLst/>
@@ -3923,8 +3947,8 @@
         </p:nvSpPr>
         <p:spPr>
           <a:xfrm>
-            <a:off x="731520" y="685800"/>
-            <a:ext cx="10515600" cy="731520"/>
+            <a:off x="731520" y="658368"/>
+            <a:ext cx="10515600" cy="640080"/>
           </a:xfrm>
           <a:prstGeom prst="rect">
             <a:avLst/>
@@ -3938,7 +3962,7 @@
           <a:lstStyle/>
           <a:p>
             <a:pPr>
-              <a:defRPr sz="2800" b="1">
+              <a:defRPr sz="2600" b="1">
                 <a:solidFill>
                   <a:srgbClr val="FFFFFF"/>
                 </a:solidFill>
@@ -3959,8 +3983,8 @@
         </p:nvSpPr>
         <p:spPr>
           <a:xfrm>
-            <a:off x="731520" y="1325880"/>
-            <a:ext cx="10515600" cy="457200"/>
+            <a:off x="731520" y="1261872"/>
+            <a:ext cx="10515600" cy="411480"/>
           </a:xfrm>
           <a:prstGeom prst="rect">
             <a:avLst/>
@@ -3974,7 +3998,7 @@
           <a:lstStyle/>
           <a:p>
             <a:pPr>
-              <a:defRPr sz="1300">
+              <a:defRPr sz="1200">
                 <a:solidFill>
                   <a:srgbClr val="94A3B8"/>
                 </a:solidFill>
@@ -3995,8 +4019,8 @@
         </p:nvSpPr>
         <p:spPr>
           <a:xfrm>
-            <a:off x="731520" y="2011680"/>
-            <a:ext cx="5120640" cy="2011680"/>
+            <a:off x="731520" y="1828800"/>
+            <a:ext cx="2926080" cy="2194560"/>
           </a:xfrm>
           <a:prstGeom prst="roundRect">
             <a:avLst/>
@@ -4025,11 +4049,11 @@
           </a:fontRef>
         </p:style>
         <p:txBody>
-          <a:bodyPr rtlCol="0" anchor="ctr" wrap="square" lIns="274320" rIns="274320" tIns="228600" bIns="228600"/>
+          <a:bodyPr rtlCol="0" anchor="ctr" wrap="square" lIns="182880" rIns="182880" tIns="137160" bIns="137160"/>
           <a:lstStyle/>
           <a:p>
             <a:pPr algn="ctr">
-              <a:defRPr sz="1600" b="1">
+              <a:defRPr sz="1300" b="1">
                 <a:solidFill>
                   <a:srgbClr val="FFFFFF"/>
                 </a:solidFill>
@@ -4037,15 +4061,15 @@
               </a:defRPr>
             </a:pPr>
             <a:r>
-              <a:t>⚡  Instant GST Billing &amp; Thermal Slips</a:t>
+              <a:t>⚡  Instant GST Billing</a:t>
             </a:r>
           </a:p>
           <a:p>
             <a:pPr>
               <a:spcBef>
-                <a:spcPts val="800"/>
+                <a:spcPts val="300"/>
               </a:spcBef>
-              <a:defRPr sz="1200">
+              <a:defRPr sz="1050">
                 <a:solidFill>
                   <a:srgbClr val="CBD5E1"/>
                 </a:solidFill>
@@ -4053,7 +4077,7 @@
               </a:defRPr>
             </a:pPr>
             <a:r>
-              <a:t>Generate professional A4 Tax Invoices or instant 58mm/80mm counter POS thermal receipts with automated GST compliance.</a:t>
+              <a:t>Generate A4 Tax Invoices or instant 58mm/80mm counter thermal slips with automated GST calculations.</a:t>
             </a:r>
           </a:p>
         </p:txBody>
@@ -4066,8 +4090,8 @@
         </p:nvSpPr>
         <p:spPr>
           <a:xfrm>
-            <a:off x="6217920" y="2011680"/>
-            <a:ext cx="5120640" cy="2011680"/>
+            <a:off x="3840480" y="1828800"/>
+            <a:ext cx="2926080" cy="2194560"/>
           </a:xfrm>
           <a:prstGeom prst="roundRect">
             <a:avLst/>
@@ -4096,11 +4120,11 @@
           </a:fontRef>
         </p:style>
         <p:txBody>
-          <a:bodyPr rtlCol="0" anchor="ctr" wrap="square" lIns="274320" rIns="274320" tIns="228600" bIns="228600"/>
+          <a:bodyPr rtlCol="0" anchor="ctr" wrap="square" lIns="182880" rIns="182880" tIns="137160" bIns="137160"/>
           <a:lstStyle/>
           <a:p>
             <a:pPr algn="ctr">
-              <a:defRPr sz="1600" b="1">
+              <a:defRPr sz="1300" b="1">
                 <a:solidFill>
                   <a:srgbClr val="FFFFFF"/>
                 </a:solidFill>
@@ -4108,15 +4132,15 @@
               </a:defRPr>
             </a:pPr>
             <a:r>
-              <a:t>🏷️  Barcode Generation &amp; Scan Engine</a:t>
+              <a:t>🏷️  Barcode Scan Engine</a:t>
             </a:r>
           </a:p>
           <a:p>
             <a:pPr>
               <a:spcBef>
-                <a:spcPts val="800"/>
+                <a:spcPts val="300"/>
               </a:spcBef>
-              <a:defRPr sz="1200">
+              <a:defRPr sz="1050">
                 <a:solidFill>
                   <a:srgbClr val="CBD5E1"/>
                 </a:solidFill>
@@ -4124,7 +4148,7 @@
               </a:defRPr>
             </a:pPr>
             <a:r>
-              <a:t>Automatically generate standard EAN-13 barcodes and QR codes. Print full A4 barcode sticker sheets in one click.</a:t>
+              <a:t>Auto-generate EAN-13 barcodes &amp; QR codes. Print full A4 barcode sticker sheets in 1 click.</a:t>
             </a:r>
           </a:p>
         </p:txBody>
@@ -4137,8 +4161,8 @@
         </p:nvSpPr>
         <p:spPr>
           <a:xfrm>
-            <a:off x="731520" y="4297680"/>
-            <a:ext cx="5120640" cy="2011680"/>
+            <a:off x="731520" y="4206240"/>
+            <a:ext cx="2926080" cy="2194560"/>
           </a:xfrm>
           <a:prstGeom prst="roundRect">
             <a:avLst/>
@@ -4167,11 +4191,11 @@
           </a:fontRef>
         </p:style>
         <p:txBody>
-          <a:bodyPr rtlCol="0" anchor="ctr" wrap="square" lIns="274320" rIns="274320" tIns="228600" bIns="228600"/>
+          <a:bodyPr rtlCol="0" anchor="ctr" wrap="square" lIns="182880" rIns="182880" tIns="137160" bIns="137160"/>
           <a:lstStyle/>
           <a:p>
             <a:pPr algn="ctr">
-              <a:defRPr sz="1600" b="1">
+              <a:defRPr sz="1300" b="1">
                 <a:solidFill>
                   <a:srgbClr val="FFFFFF"/>
                 </a:solidFill>
@@ -4179,15 +4203,15 @@
               </a:defRPr>
             </a:pPr>
             <a:r>
-              <a:t>💳  Digital Ledger &amp; WhatsApp Reminders</a:t>
+              <a:t>💳  Digital Ledger Khata</a:t>
             </a:r>
           </a:p>
           <a:p>
             <a:pPr>
               <a:spcBef>
-                <a:spcPts val="800"/>
+                <a:spcPts val="300"/>
               </a:spcBef>
-              <a:defRPr sz="1200">
+              <a:defRPr sz="1050">
                 <a:solidFill>
                   <a:srgbClr val="CBD5E1"/>
                 </a:solidFill>
@@ -4195,7 +4219,7 @@
               </a:defRPr>
             </a:pPr>
             <a:r>
-              <a:t>Track real-time customer balances. Send automated WhatsApp payment reminders with direct online payment links.</a:t>
+              <a:t>Real-time party balances with automated WhatsApp payment links and instant settlement.</a:t>
             </a:r>
           </a:p>
         </p:txBody>
@@ -4208,8 +4232,8 @@
         </p:nvSpPr>
         <p:spPr>
           <a:xfrm>
-            <a:off x="6217920" y="4297680"/>
-            <a:ext cx="5120640" cy="2011680"/>
+            <a:off x="3840480" y="4206240"/>
+            <a:ext cx="2926080" cy="2194560"/>
           </a:xfrm>
           <a:prstGeom prst="roundRect">
             <a:avLst/>
@@ -4238,11 +4262,11 @@
           </a:fontRef>
         </p:style>
         <p:txBody>
-          <a:bodyPr rtlCol="0" anchor="ctr" wrap="square" lIns="274320" rIns="274320" tIns="228600" bIns="228600"/>
+          <a:bodyPr rtlCol="0" anchor="ctr" wrap="square" lIns="182880" rIns="182880" tIns="137160" bIns="137160"/>
           <a:lstStyle/>
           <a:p>
             <a:pPr algn="ctr">
-              <a:defRPr sz="1600" b="1">
+              <a:defRPr sz="1300" b="1">
                 <a:solidFill>
                   <a:srgbClr val="FFFFFF"/>
                 </a:solidFill>
@@ -4250,15 +4274,15 @@
               </a:defRPr>
             </a:pPr>
             <a:r>
-              <a:t>👥  Multi-Role Counter Interfaces</a:t>
+              <a:t>👥  Multi-Role Portals</a:t>
             </a:r>
           </a:p>
           <a:p>
             <a:pPr>
               <a:spcBef>
-                <a:spcPts val="800"/>
+                <a:spcPts val="300"/>
               </a:spcBef>
-              <a:defRPr sz="1200">
+              <a:defRPr sz="1050">
                 <a:solidFill>
                   <a:srgbClr val="CBD5E1"/>
                 </a:solidFill>
@@ -4266,11 +4290,35 @@
               </a:defRPr>
             </a:pPr>
             <a:r>
-              <a:t>Clean, dedicated portals for Store Owners, Cashier POS counters, Delivery Partners, and Accountants.</a:t>
-            </a:r>
-          </a:p>
-        </p:txBody>
-      </p:sp>
+              <a:t>Tailored views for Store Owners, Cashier POS counters, Delivery Partners, and Accountants.</a:t>
+            </a:r>
+          </a:p>
+        </p:txBody>
+      </p:sp>
+      <p:pic>
+        <p:nvPicPr>
+          <p:cNvPr id="10" name="Picture 9" descr="dashboard.png"/>
+          <p:cNvPicPr>
+            <a:picLocks noChangeAspect="1"/>
+          </p:cNvPicPr>
+          <p:nvPr/>
+        </p:nvPicPr>
+        <p:blipFill>
+          <a:blip r:embed="rId2"/>
+          <a:stretch>
+            <a:fillRect/>
+          </a:stretch>
+        </p:blipFill>
+        <p:spPr>
+          <a:xfrm>
+            <a:off x="7040880" y="1828800"/>
+            <a:ext cx="4389120" cy="2084832"/>
+          </a:xfrm>
+          <a:prstGeom prst="rect">
+            <a:avLst/>
+          </a:prstGeom>
+        </p:spPr>
+      </p:pic>
     </p:spTree>
   </p:cSld>
   <p:clrMapOvr>
@@ -4341,7 +4389,7 @@
         <p:spPr>
           <a:xfrm>
             <a:off x="731520" y="365760"/>
-            <a:ext cx="4114800" cy="365760"/>
+            <a:ext cx="5486400" cy="320040"/>
           </a:xfrm>
           <a:prstGeom prst="rect">
             <a:avLst/>
@@ -4376,8 +4424,8 @@
         </p:nvSpPr>
         <p:spPr>
           <a:xfrm>
-            <a:off x="731520" y="685800"/>
-            <a:ext cx="10515600" cy="731520"/>
+            <a:off x="731520" y="658368"/>
+            <a:ext cx="10515600" cy="640080"/>
           </a:xfrm>
           <a:prstGeom prst="rect">
             <a:avLst/>
@@ -4391,7 +4439,7 @@
           <a:lstStyle/>
           <a:p>
             <a:pPr>
-              <a:defRPr sz="2800" b="1">
+              <a:defRPr sz="2600" b="1">
                 <a:solidFill>
                   <a:srgbClr val="FFFFFF"/>
                 </a:solidFill>
@@ -4412,8 +4460,8 @@
         </p:nvSpPr>
         <p:spPr>
           <a:xfrm>
-            <a:off x="731520" y="1325880"/>
-            <a:ext cx="10515600" cy="457200"/>
+            <a:off x="731520" y="1261872"/>
+            <a:ext cx="10515600" cy="411480"/>
           </a:xfrm>
           <a:prstGeom prst="rect">
             <a:avLst/>
@@ -4427,7 +4475,7 @@
           <a:lstStyle/>
           <a:p>
             <a:pPr>
-              <a:defRPr sz="1300">
+              <a:defRPr sz="1200">
                 <a:solidFill>
                   <a:srgbClr val="94A3B8"/>
                 </a:solidFill>
@@ -4448,8 +4496,8 @@
         </p:nvSpPr>
         <p:spPr>
           <a:xfrm>
-            <a:off x="731520" y="2011680"/>
-            <a:ext cx="5120640" cy="2011680"/>
+            <a:off x="731520" y="1828800"/>
+            <a:ext cx="2926080" cy="2194560"/>
           </a:xfrm>
           <a:prstGeom prst="roundRect">
             <a:avLst/>
@@ -4478,11 +4526,11 @@
           </a:fontRef>
         </p:style>
         <p:txBody>
-          <a:bodyPr rtlCol="0" anchor="ctr" wrap="square" lIns="274320" rIns="274320" tIns="228600" bIns="228600"/>
+          <a:bodyPr rtlCol="0" anchor="ctr" wrap="square" lIns="182880" rIns="182880" tIns="137160" bIns="137160"/>
           <a:lstStyle/>
           <a:p>
             <a:pPr algn="ctr">
-              <a:defRPr sz="1600" b="1">
+              <a:defRPr sz="1300" b="1">
                 <a:solidFill>
                   <a:srgbClr val="FFFFFF"/>
                 </a:solidFill>
@@ -4490,15 +4538,15 @@
               </a:defRPr>
             </a:pPr>
             <a:r>
-              <a:t>🧾  Sales &amp; Invoicing Module</a:t>
+              <a:t>🧾  Sales &amp; Invoicing</a:t>
             </a:r>
           </a:p>
           <a:p>
             <a:pPr>
               <a:spcBef>
-                <a:spcPts val="800"/>
+                <a:spcPts val="300"/>
               </a:spcBef>
-              <a:defRPr sz="1200">
+              <a:defRPr sz="1050">
                 <a:solidFill>
                   <a:srgbClr val="CBD5E1"/>
                 </a:solidFill>
@@ -4506,7 +4554,7 @@
               </a:defRPr>
             </a:pPr>
             <a:r>
-              <a:t>Create customized invoices with dynamic discounts, multi-tax GST slabs, and instant PDF downloads with one click.</a:t>
+              <a:t>Fast billing counter with barcode scanner support, line discounts, and PDF downloads.</a:t>
             </a:r>
           </a:p>
         </p:txBody>
@@ -4519,8 +4567,8 @@
         </p:nvSpPr>
         <p:spPr>
           <a:xfrm>
-            <a:off x="6217920" y="2011680"/>
-            <a:ext cx="5120640" cy="2011680"/>
+            <a:off x="3840480" y="1828800"/>
+            <a:ext cx="2926080" cy="2194560"/>
           </a:xfrm>
           <a:prstGeom prst="roundRect">
             <a:avLst/>
@@ -4549,11 +4597,11 @@
           </a:fontRef>
         </p:style>
         <p:txBody>
-          <a:bodyPr rtlCol="0" anchor="ctr" wrap="square" lIns="274320" rIns="274320" tIns="228600" bIns="228600"/>
+          <a:bodyPr rtlCol="0" anchor="ctr" wrap="square" lIns="182880" rIns="182880" tIns="137160" bIns="137160"/>
           <a:lstStyle/>
           <a:p>
             <a:pPr algn="ctr">
-              <a:defRPr sz="1600" b="1">
+              <a:defRPr sz="1300" b="1">
                 <a:solidFill>
                   <a:srgbClr val="FFFFFF"/>
                 </a:solidFill>
@@ -4561,15 +4609,15 @@
               </a:defRPr>
             </a:pPr>
             <a:r>
-              <a:t>🛒  Purchase &amp; Vendor Tracking</a:t>
+              <a:t>🛒  Purchase &amp; Suppliers</a:t>
             </a:r>
           </a:p>
           <a:p>
             <a:pPr>
               <a:spcBef>
-                <a:spcPts val="800"/>
+                <a:spcPts val="300"/>
               </a:spcBef>
-              <a:defRPr sz="1200">
+              <a:defRPr sz="1050">
                 <a:solidFill>
                   <a:srgbClr val="CBD5E1"/>
                 </a:solidFill>
@@ -4577,7 +4625,7 @@
               </a:defRPr>
             </a:pPr>
             <a:r>
-              <a:t>Record supplier stock-in orders, manage accounts payable, and track supplier payment histories with zero errors.</a:t>
+              <a:t>Track vendor stock-in shipments, payment terms, and accounts payable automatically.</a:t>
             </a:r>
           </a:p>
         </p:txBody>
@@ -4590,8 +4638,8 @@
         </p:nvSpPr>
         <p:spPr>
           <a:xfrm>
-            <a:off x="731520" y="4297680"/>
-            <a:ext cx="5120640" cy="2011680"/>
+            <a:off x="731520" y="4206240"/>
+            <a:ext cx="2926080" cy="2194560"/>
           </a:xfrm>
           <a:prstGeom prst="roundRect">
             <a:avLst/>
@@ -4620,11 +4668,11 @@
           </a:fontRef>
         </p:style>
         <p:txBody>
-          <a:bodyPr rtlCol="0" anchor="ctr" wrap="square" lIns="274320" rIns="274320" tIns="228600" bIns="228600"/>
+          <a:bodyPr rtlCol="0" anchor="ctr" wrap="square" lIns="182880" rIns="182880" tIns="137160" bIns="137160"/>
           <a:lstStyle/>
           <a:p>
             <a:pPr algn="ctr">
-              <a:defRPr sz="1600" b="1">
+              <a:defRPr sz="1300" b="1">
                 <a:solidFill>
                   <a:srgbClr val="FFFFFF"/>
                 </a:solidFill>
@@ -4632,15 +4680,15 @@
               </a:defRPr>
             </a:pPr>
             <a:r>
-              <a:t>💰  Expense &amp; Cash Flow Ledger</a:t>
+              <a:t>💰  Expense Ledger</a:t>
             </a:r>
           </a:p>
           <a:p>
             <a:pPr>
               <a:spcBef>
-                <a:spcPts val="800"/>
+                <a:spcPts val="300"/>
               </a:spcBef>
-              <a:defRPr sz="1200">
+              <a:defRPr sz="1050">
                 <a:solidFill>
                   <a:srgbClr val="CBD5E1"/>
                 </a:solidFill>
@@ -4648,7 +4696,7 @@
               </a:defRPr>
             </a:pPr>
             <a:r>
-              <a:t>Categorize daily shop expenses (rent, salaries, utilities) to get an accurate daily net profit and cash-in-hand calculation.</a:t>
+              <a:t>Track daily operational expenses (rent, salaries, utilities) for true net profit tracking.</a:t>
             </a:r>
           </a:p>
         </p:txBody>
@@ -4661,8 +4709,8 @@
         </p:nvSpPr>
         <p:spPr>
           <a:xfrm>
-            <a:off x="6217920" y="4297680"/>
-            <a:ext cx="5120640" cy="2011680"/>
+            <a:off x="3840480" y="4206240"/>
+            <a:ext cx="2926080" cy="2194560"/>
           </a:xfrm>
           <a:prstGeom prst="roundRect">
             <a:avLst/>
@@ -4691,11 +4739,11 @@
           </a:fontRef>
         </p:style>
         <p:txBody>
-          <a:bodyPr rtlCol="0" anchor="ctr" wrap="square" lIns="274320" rIns="274320" tIns="228600" bIns="228600"/>
+          <a:bodyPr rtlCol="0" anchor="ctr" wrap="square" lIns="182880" rIns="182880" tIns="137160" bIns="137160"/>
           <a:lstStyle/>
           <a:p>
             <a:pPr algn="ctr">
-              <a:defRPr sz="1600" b="1">
+              <a:defRPr sz="1300" b="1">
                 <a:solidFill>
                   <a:srgbClr val="FFFFFF"/>
                 </a:solidFill>
@@ -4703,15 +4751,15 @@
               </a:defRPr>
             </a:pPr>
             <a:r>
-              <a:t>🤝  Parties &amp; Khata Management</a:t>
+              <a:t>🤝  Parties &amp; Khata CRM</a:t>
             </a:r>
           </a:p>
           <a:p>
             <a:pPr>
               <a:spcBef>
-                <a:spcPts val="800"/>
+                <a:spcPts val="300"/>
               </a:spcBef>
-              <a:defRPr sz="1200">
+              <a:defRPr sz="1050">
                 <a:solidFill>
                   <a:srgbClr val="CBD5E1"/>
                 </a:solidFill>
@@ -4719,11 +4767,35 @@
               </a:defRPr>
             </a:pPr>
             <a:r>
-              <a:t>Complete 360-degree CRM with detailed credit ledgers, contact directories, and automated settlement tracking.</a:t>
-            </a:r>
-          </a:p>
-        </p:txBody>
-      </p:sp>
+              <a:t>Complete directory with credit limits, transaction histories, and digital ledger statements.</a:t>
+            </a:r>
+          </a:p>
+        </p:txBody>
+      </p:sp>
+      <p:pic>
+        <p:nvPicPr>
+          <p:cNvPr id="10" name="Picture 9" descr="invoices.png"/>
+          <p:cNvPicPr>
+            <a:picLocks noChangeAspect="1"/>
+          </p:cNvPicPr>
+          <p:nvPr/>
+        </p:nvPicPr>
+        <p:blipFill>
+          <a:blip r:embed="rId2"/>
+          <a:stretch>
+            <a:fillRect/>
+          </a:stretch>
+        </p:blipFill>
+        <p:spPr>
+          <a:xfrm>
+            <a:off x="7040880" y="1828800"/>
+            <a:ext cx="4389120" cy="2084832"/>
+          </a:xfrm>
+          <a:prstGeom prst="rect">
+            <a:avLst/>
+          </a:prstGeom>
+        </p:spPr>
+      </p:pic>
     </p:spTree>
   </p:cSld>
   <p:clrMapOvr>
@@ -4794,7 +4866,7 @@
         <p:spPr>
           <a:xfrm>
             <a:off x="731520" y="365760"/>
-            <a:ext cx="4114800" cy="365760"/>
+            <a:ext cx="5486400" cy="320040"/>
           </a:xfrm>
           <a:prstGeom prst="rect">
             <a:avLst/>
@@ -4829,8 +4901,8 @@
         </p:nvSpPr>
         <p:spPr>
           <a:xfrm>
-            <a:off x="731520" y="685800"/>
-            <a:ext cx="10515600" cy="731520"/>
+            <a:off x="731520" y="658368"/>
+            <a:ext cx="10515600" cy="640080"/>
           </a:xfrm>
           <a:prstGeom prst="rect">
             <a:avLst/>
@@ -4844,7 +4916,7 @@
           <a:lstStyle/>
           <a:p>
             <a:pPr>
-              <a:defRPr sz="2800" b="1">
+              <a:defRPr sz="2600" b="1">
                 <a:solidFill>
                   <a:srgbClr val="FFFFFF"/>
                 </a:solidFill>
@@ -4865,8 +4937,8 @@
         </p:nvSpPr>
         <p:spPr>
           <a:xfrm>
-            <a:off x="731520" y="1325880"/>
-            <a:ext cx="10515600" cy="457200"/>
+            <a:off x="731520" y="1261872"/>
+            <a:ext cx="10515600" cy="411480"/>
           </a:xfrm>
           <a:prstGeom prst="rect">
             <a:avLst/>
@@ -4880,7 +4952,7 @@
           <a:lstStyle/>
           <a:p>
             <a:pPr>
-              <a:defRPr sz="1300">
+              <a:defRPr sz="1200">
                 <a:solidFill>
                   <a:srgbClr val="94A3B8"/>
                 </a:solidFill>
@@ -4901,8 +4973,8 @@
         </p:nvSpPr>
         <p:spPr>
           <a:xfrm>
-            <a:off x="731520" y="2011680"/>
-            <a:ext cx="5486400" cy="1280160"/>
+            <a:off x="731520" y="1828800"/>
+            <a:ext cx="5852160" cy="1371600"/>
           </a:xfrm>
           <a:prstGeom prst="roundRect">
             <a:avLst/>
@@ -4931,11 +5003,11 @@
           </a:fontRef>
         </p:style>
         <p:txBody>
-          <a:bodyPr rtlCol="0" anchor="ctr" wrap="square" lIns="274320" rIns="274320" tIns="228600" bIns="228600"/>
+          <a:bodyPr rtlCol="0" anchor="ctr" wrap="square" lIns="182880" rIns="182880" tIns="137160" bIns="137160"/>
           <a:lstStyle/>
           <a:p>
             <a:pPr algn="ctr">
-              <a:defRPr sz="1600" b="1">
+              <a:defRPr sz="1300" b="1">
                 <a:solidFill>
                   <a:srgbClr val="FFFFFF"/>
                 </a:solidFill>
@@ -4949,9 +5021,9 @@
           <a:p>
             <a:pPr>
               <a:spcBef>
-                <a:spcPts val="800"/>
+                <a:spcPts val="300"/>
               </a:spcBef>
-              <a:defRPr sz="1200">
+              <a:defRPr sz="1050">
                 <a:solidFill>
                   <a:srgbClr val="CBD5E1"/>
                 </a:solidFill>
@@ -4972,8 +5044,8 @@
         </p:nvSpPr>
         <p:spPr>
           <a:xfrm>
-            <a:off x="731520" y="3474720"/>
-            <a:ext cx="5486400" cy="1280160"/>
+            <a:off x="731520" y="3383280"/>
+            <a:ext cx="5852160" cy="1371600"/>
           </a:xfrm>
           <a:prstGeom prst="roundRect">
             <a:avLst/>
@@ -5002,11 +5074,11 @@
           </a:fontRef>
         </p:style>
         <p:txBody>
-          <a:bodyPr rtlCol="0" anchor="ctr" wrap="square" lIns="274320" rIns="274320" tIns="228600" bIns="228600"/>
+          <a:bodyPr rtlCol="0" anchor="ctr" wrap="square" lIns="182880" rIns="182880" tIns="137160" bIns="137160"/>
           <a:lstStyle/>
           <a:p>
             <a:pPr algn="ctr">
-              <a:defRPr sz="1600" b="1">
+              <a:defRPr sz="1300" b="1">
                 <a:solidFill>
                   <a:srgbClr val="FFFFFF"/>
                 </a:solidFill>
@@ -5014,15 +5086,15 @@
               </a:defRPr>
             </a:pPr>
             <a:r>
-              <a:t>🗺️  Live GPS Telematics &amp; Leaflet Map</a:t>
+              <a:t>🗺️  Live GPS Telematics &amp; Interactive Map</a:t>
             </a:r>
           </a:p>
           <a:p>
             <a:pPr>
               <a:spcBef>
-                <a:spcPts val="800"/>
+                <a:spcPts val="300"/>
               </a:spcBef>
-              <a:defRPr sz="1200">
+              <a:defRPr sz="1050">
                 <a:solidFill>
                   <a:srgbClr val="CBD5E1"/>
                 </a:solidFill>
@@ -5030,7 +5102,7 @@
               </a:defRPr>
             </a:pPr>
             <a:r>
-              <a:t>Live moving driver marker displaying actual route geometry, speed, and real-time vehicle coordinates.</a:t>
+              <a:t>Live moving driver marker powered by Leaflet, displaying actual route geometry and coordinates.</a:t>
             </a:r>
           </a:p>
         </p:txBody>
@@ -5044,7 +5116,7 @@
         <p:spPr>
           <a:xfrm>
             <a:off x="731520" y="4937760"/>
-            <a:ext cx="5486400" cy="1280160"/>
+            <a:ext cx="5852160" cy="1371600"/>
           </a:xfrm>
           <a:prstGeom prst="roundRect">
             <a:avLst/>
@@ -5073,11 +5145,11 @@
           </a:fontRef>
         </p:style>
         <p:txBody>
-          <a:bodyPr rtlCol="0" anchor="ctr" wrap="square" lIns="274320" rIns="274320" tIns="228600" bIns="228600"/>
+          <a:bodyPr rtlCol="0" anchor="ctr" wrap="square" lIns="182880" rIns="182880" tIns="137160" bIns="137160"/>
           <a:lstStyle/>
           <a:p>
             <a:pPr algn="ctr">
-              <a:defRPr sz="1600" b="1">
+              <a:defRPr sz="1300" b="1">
                 <a:solidFill>
                   <a:srgbClr val="FFFFFF"/>
                 </a:solidFill>
@@ -5091,9 +5163,9 @@
           <a:p>
             <a:pPr>
               <a:spcBef>
-                <a:spcPts val="800"/>
+                <a:spcPts val="300"/>
               </a:spcBef>
-              <a:defRPr sz="1200">
+              <a:defRPr sz="1050">
                 <a:solidFill>
                   <a:srgbClr val="CBD5E1"/>
                 </a:solidFill>
@@ -5122,8 +5194,8 @@
         </p:blipFill>
         <p:spPr>
           <a:xfrm>
-            <a:off x="6583680" y="2011680"/>
-            <a:ext cx="4846320" cy="2302002"/>
+            <a:off x="6858000" y="1828800"/>
+            <a:ext cx="4572000" cy="2171700"/>
           </a:xfrm>
           <a:prstGeom prst="rect">
             <a:avLst/>
@@ -5200,7 +5272,7 @@
         <p:spPr>
           <a:xfrm>
             <a:off x="731520" y="365760"/>
-            <a:ext cx="4114800" cy="365760"/>
+            <a:ext cx="5486400" cy="320040"/>
           </a:xfrm>
           <a:prstGeom prst="rect">
             <a:avLst/>
@@ -5235,8 +5307,8 @@
         </p:nvSpPr>
         <p:spPr>
           <a:xfrm>
-            <a:off x="731520" y="685800"/>
-            <a:ext cx="10515600" cy="731520"/>
+            <a:off x="731520" y="658368"/>
+            <a:ext cx="10515600" cy="640080"/>
           </a:xfrm>
           <a:prstGeom prst="rect">
             <a:avLst/>
@@ -5250,7 +5322,7 @@
           <a:lstStyle/>
           <a:p>
             <a:pPr>
-              <a:defRPr sz="2800" b="1">
+              <a:defRPr sz="2600" b="1">
                 <a:solidFill>
                   <a:srgbClr val="FFFFFF"/>
                 </a:solidFill>
@@ -5271,8 +5343,8 @@
         </p:nvSpPr>
         <p:spPr>
           <a:xfrm>
-            <a:off x="731520" y="1325880"/>
-            <a:ext cx="10515600" cy="457200"/>
+            <a:off x="731520" y="1261872"/>
+            <a:ext cx="10515600" cy="411480"/>
           </a:xfrm>
           <a:prstGeom prst="rect">
             <a:avLst/>
@@ -5286,7 +5358,7 @@
           <a:lstStyle/>
           <a:p>
             <a:pPr>
-              <a:defRPr sz="1300">
+              <a:defRPr sz="1200">
                 <a:solidFill>
                   <a:srgbClr val="94A3B8"/>
                 </a:solidFill>
@@ -5307,8 +5379,8 @@
         </p:nvSpPr>
         <p:spPr>
           <a:xfrm>
-            <a:off x="731520" y="2011680"/>
-            <a:ext cx="5120640" cy="2011680"/>
+            <a:off x="731520" y="1828800"/>
+            <a:ext cx="2926080" cy="2194560"/>
           </a:xfrm>
           <a:prstGeom prst="roundRect">
             <a:avLst/>
@@ -5337,11 +5409,11 @@
           </a:fontRef>
         </p:style>
         <p:txBody>
-          <a:bodyPr rtlCol="0" anchor="ctr" wrap="square" lIns="274320" rIns="274320" tIns="228600" bIns="228600"/>
+          <a:bodyPr rtlCol="0" anchor="ctr" wrap="square" lIns="182880" rIns="182880" tIns="137160" bIns="137160"/>
           <a:lstStyle/>
           <a:p>
             <a:pPr algn="ctr">
-              <a:defRPr sz="1600" b="1">
+              <a:defRPr sz="1300" b="1">
                 <a:solidFill>
                   <a:srgbClr val="FFFFFF"/>
                 </a:solidFill>
@@ -5349,15 +5421,15 @@
               </a:defRPr>
             </a:pPr>
             <a:r>
-              <a:t>⚛️  Frontend: React 19 + Vite</a:t>
+              <a:t>⚛️  React 19 + Vite Frontend</a:t>
             </a:r>
           </a:p>
           <a:p>
             <a:pPr>
               <a:spcBef>
-                <a:spcPts val="800"/>
+                <a:spcPts val="300"/>
               </a:spcBef>
-              <a:defRPr sz="1200">
+              <a:defRPr sz="1050">
                 <a:solidFill>
                   <a:srgbClr val="CBD5E1"/>
                 </a:solidFill>
@@ -5365,7 +5437,7 @@
               </a:defRPr>
             </a:pPr>
             <a:r>
-              <a:t>Blazing-fast client bundle, instant route transitions, zero page reloads, and seamless responsiveness across laptops, tablets, and mobile.</a:t>
+              <a:t>Sub-second transitions, responsive UI on laptops, tablets, and phones.</a:t>
             </a:r>
           </a:p>
         </p:txBody>
@@ -5378,8 +5450,8 @@
         </p:nvSpPr>
         <p:spPr>
           <a:xfrm>
-            <a:off x="6217920" y="2011680"/>
-            <a:ext cx="5120640" cy="2011680"/>
+            <a:off x="3840480" y="1828800"/>
+            <a:ext cx="2926080" cy="2194560"/>
           </a:xfrm>
           <a:prstGeom prst="roundRect">
             <a:avLst/>
@@ -5408,11 +5480,11 @@
           </a:fontRef>
         </p:style>
         <p:txBody>
-          <a:bodyPr rtlCol="0" anchor="ctr" wrap="square" lIns="274320" rIns="274320" tIns="228600" bIns="228600"/>
+          <a:bodyPr rtlCol="0" anchor="ctr" wrap="square" lIns="182880" rIns="182880" tIns="137160" bIns="137160"/>
           <a:lstStyle/>
           <a:p>
             <a:pPr algn="ctr">
-              <a:defRPr sz="1600" b="1">
+              <a:defRPr sz="1300" b="1">
                 <a:solidFill>
                   <a:srgbClr val="FFFFFF"/>
                 </a:solidFill>
@@ -5420,15 +5492,15 @@
               </a:defRPr>
             </a:pPr>
             <a:r>
-              <a:t>🟢  Backend: Node.js &amp; Express</a:t>
+              <a:t>🟢  Node.js &amp; Express Backend</a:t>
             </a:r>
           </a:p>
           <a:p>
             <a:pPr>
               <a:spcBef>
-                <a:spcPts val="800"/>
+                <a:spcPts val="300"/>
               </a:spcBef>
-              <a:defRPr sz="1200">
+              <a:defRPr sz="1050">
                 <a:solidFill>
                   <a:srgbClr val="CBD5E1"/>
                 </a:solidFill>
@@ -5436,7 +5508,7 @@
               </a:defRPr>
             </a:pPr>
             <a:r>
-              <a:t>High-throughput RESTful architecture powering live GPS streams, PDF invoice generators (PDFKit), and barcode rendering.</a:t>
+              <a:t>High-throughput REST APIs powering live telematics and PDFKit rendering.</a:t>
             </a:r>
           </a:p>
         </p:txBody>
@@ -5449,8 +5521,8 @@
         </p:nvSpPr>
         <p:spPr>
           <a:xfrm>
-            <a:off x="731520" y="4297680"/>
-            <a:ext cx="5120640" cy="2011680"/>
+            <a:off x="731520" y="4206240"/>
+            <a:ext cx="2926080" cy="2194560"/>
           </a:xfrm>
           <a:prstGeom prst="roundRect">
             <a:avLst/>
@@ -5479,11 +5551,11 @@
           </a:fontRef>
         </p:style>
         <p:txBody>
-          <a:bodyPr rtlCol="0" anchor="ctr" wrap="square" lIns="274320" rIns="274320" tIns="228600" bIns="228600"/>
+          <a:bodyPr rtlCol="0" anchor="ctr" wrap="square" lIns="182880" rIns="182880" tIns="137160" bIns="137160"/>
           <a:lstStyle/>
           <a:p>
             <a:pPr algn="ctr">
-              <a:defRPr sz="1600" b="1">
+              <a:defRPr sz="1300" b="1">
                 <a:solidFill>
                   <a:srgbClr val="FFFFFF"/>
                 </a:solidFill>
@@ -5491,15 +5563,15 @@
               </a:defRPr>
             </a:pPr>
             <a:r>
-              <a:t>🍃  Database: MongoDB Atlas</a:t>
+              <a:t>🍃  MongoDB Atlas Cloud</a:t>
             </a:r>
           </a:p>
           <a:p>
             <a:pPr>
               <a:spcBef>
-                <a:spcPts val="800"/>
+                <a:spcPts val="300"/>
               </a:spcBef>
-              <a:defRPr sz="1200">
+              <a:defRPr sz="1050">
                 <a:solidFill>
                   <a:srgbClr val="CBD5E1"/>
                 </a:solidFill>
@@ -5507,7 +5579,7 @@
               </a:defRPr>
             </a:pPr>
             <a:r>
-              <a:t>Cloud-native NoSQL database handling dynamic catalog structures, nested ledger transactions, and geospatial delivery points.</a:t>
+              <a:t>Cloud NoSQL database handling dynamic catalogs and geospatial coordinates.</a:t>
             </a:r>
           </a:p>
         </p:txBody>
@@ -5520,8 +5592,8 @@
         </p:nvSpPr>
         <p:spPr>
           <a:xfrm>
-            <a:off x="6217920" y="4297680"/>
-            <a:ext cx="5120640" cy="2011680"/>
+            <a:off x="3840480" y="4206240"/>
+            <a:ext cx="2926080" cy="2194560"/>
           </a:xfrm>
           <a:prstGeom prst="roundRect">
             <a:avLst/>
@@ -5550,11 +5622,11 @@
           </a:fontRef>
         </p:style>
         <p:txBody>
-          <a:bodyPr rtlCol="0" anchor="ctr" wrap="square" lIns="274320" rIns="274320" tIns="228600" bIns="228600"/>
+          <a:bodyPr rtlCol="0" anchor="ctr" wrap="square" lIns="182880" rIns="182880" tIns="137160" bIns="137160"/>
           <a:lstStyle/>
           <a:p>
             <a:pPr algn="ctr">
-              <a:defRPr sz="1600" b="1">
+              <a:defRPr sz="1300" b="1">
                 <a:solidFill>
                   <a:srgbClr val="FFFFFF"/>
                 </a:solidFill>
@@ -5562,15 +5634,15 @@
               </a:defRPr>
             </a:pPr>
             <a:r>
-              <a:t>🔒  Enterprise Security &amp; Compliance</a:t>
+              <a:t>🔒  Enterprise Security</a:t>
             </a:r>
           </a:p>
           <a:p>
             <a:pPr>
               <a:spcBef>
-                <a:spcPts val="800"/>
+                <a:spcPts val="300"/>
               </a:spcBef>
-              <a:defRPr sz="1200">
+              <a:defRPr sz="1050">
                 <a:solidFill>
                   <a:srgbClr val="CBD5E1"/>
                 </a:solidFill>
@@ -5578,11 +5650,35 @@
               </a:defRPr>
             </a:pPr>
             <a:r>
-              <a:t>Strict JWT role-based access control (Admin, Driver, Cashier), encrypted credentials, and automated GSTR-1 audit exports.</a:t>
-            </a:r>
-          </a:p>
-        </p:txBody>
-      </p:sp>
+              <a:t>JWT role-based access control, encrypted sessions, and automated GSTR-1 exports.</a:t>
+            </a:r>
+          </a:p>
+        </p:txBody>
+      </p:sp>
+      <p:pic>
+        <p:nvPicPr>
+          <p:cNvPr id="10" name="Picture 9" descr="techstack.jpg"/>
+          <p:cNvPicPr>
+            <a:picLocks noChangeAspect="1"/>
+          </p:cNvPicPr>
+          <p:nvPr/>
+        </p:nvPicPr>
+        <p:blipFill>
+          <a:blip r:embed="rId2"/>
+          <a:stretch>
+            <a:fillRect/>
+          </a:stretch>
+        </p:blipFill>
+        <p:spPr>
+          <a:xfrm>
+            <a:off x="7040880" y="1828800"/>
+            <a:ext cx="4389120" cy="2449741"/>
+          </a:xfrm>
+          <a:prstGeom prst="rect">
+            <a:avLst/>
+          </a:prstGeom>
+        </p:spPr>
+      </p:pic>
     </p:spTree>
   </p:cSld>
   <p:clrMapOvr>
@@ -5653,7 +5749,7 @@
         <p:spPr>
           <a:xfrm>
             <a:off x="731520" y="365760"/>
-            <a:ext cx="4114800" cy="365760"/>
+            <a:ext cx="5486400" cy="320040"/>
           </a:xfrm>
           <a:prstGeom prst="rect">
             <a:avLst/>
@@ -5688,8 +5784,8 @@
         </p:nvSpPr>
         <p:spPr>
           <a:xfrm>
-            <a:off x="731520" y="685800"/>
-            <a:ext cx="10515600" cy="731520"/>
+            <a:off x="731520" y="658368"/>
+            <a:ext cx="10515600" cy="640080"/>
           </a:xfrm>
           <a:prstGeom prst="rect">
             <a:avLst/>
@@ -5703,7 +5799,7 @@
           <a:lstStyle/>
           <a:p>
             <a:pPr>
-              <a:defRPr sz="2800" b="1">
+              <a:defRPr sz="2600" b="1">
                 <a:solidFill>
                   <a:srgbClr val="FFFFFF"/>
                 </a:solidFill>
@@ -5724,8 +5820,8 @@
         </p:nvSpPr>
         <p:spPr>
           <a:xfrm>
-            <a:off x="731520" y="1325880"/>
-            <a:ext cx="10515600" cy="457200"/>
+            <a:off x="731520" y="1261872"/>
+            <a:ext cx="10515600" cy="411480"/>
           </a:xfrm>
           <a:prstGeom prst="rect">
             <a:avLst/>
@@ -5739,7 +5835,7 @@
           <a:lstStyle/>
           <a:p>
             <a:pPr>
-              <a:defRPr sz="1300">
+              <a:defRPr sz="1200">
                 <a:solidFill>
                   <a:srgbClr val="94A3B8"/>
                 </a:solidFill>
@@ -5760,8 +5856,8 @@
         </p:nvSpPr>
         <p:spPr>
           <a:xfrm>
-            <a:off x="731520" y="2011680"/>
-            <a:ext cx="5120640" cy="2011680"/>
+            <a:off x="731520" y="1828800"/>
+            <a:ext cx="2926080" cy="2194560"/>
           </a:xfrm>
           <a:prstGeom prst="roundRect">
             <a:avLst/>
@@ -5790,11 +5886,11 @@
           </a:fontRef>
         </p:style>
         <p:txBody>
-          <a:bodyPr rtlCol="0" anchor="ctr" wrap="square" lIns="274320" rIns="274320" tIns="228600" bIns="228600"/>
+          <a:bodyPr rtlCol="0" anchor="ctr" wrap="square" lIns="182880" rIns="182880" tIns="137160" bIns="137160"/>
           <a:lstStyle/>
           <a:p>
             <a:pPr algn="ctr">
-              <a:defRPr sz="2400" b="1">
+              <a:defRPr sz="1800" b="1">
                 <a:solidFill>
                   <a:srgbClr val="10B981"/>
                 </a:solidFill>
@@ -5807,7 +5903,7 @@
           </a:p>
           <a:p>
             <a:pPr>
-              <a:defRPr sz="1600" b="1">
+              <a:defRPr sz="1300" b="1">
                 <a:solidFill>
                   <a:srgbClr val="FFFFFF"/>
                 </a:solidFill>
@@ -5821,9 +5917,9 @@
           <a:p>
             <a:pPr>
               <a:spcBef>
-                <a:spcPts val="800"/>
+                <a:spcPts val="300"/>
               </a:spcBef>
-              <a:defRPr sz="1200">
+              <a:defRPr sz="1050">
                 <a:solidFill>
                   <a:srgbClr val="CBD5E1"/>
                 </a:solidFill>
@@ -5831,7 +5927,7 @@
               </a:defRPr>
             </a:pPr>
             <a:r>
-              <a:t>Automated day-end book closing, tax calculation, and inventory reconciliation eliminate manual paperwork.</a:t>
+              <a:t>Automated day-end book closing and stock reconciliation eliminate manual paperwork.</a:t>
             </a:r>
           </a:p>
         </p:txBody>
@@ -5844,8 +5940,8 @@
         </p:nvSpPr>
         <p:spPr>
           <a:xfrm>
-            <a:off x="6217920" y="2011680"/>
-            <a:ext cx="5120640" cy="2011680"/>
+            <a:off x="3840480" y="1828800"/>
+            <a:ext cx="2926080" cy="2194560"/>
           </a:xfrm>
           <a:prstGeom prst="roundRect">
             <a:avLst/>
@@ -5874,11 +5970,11 @@
           </a:fontRef>
         </p:style>
         <p:txBody>
-          <a:bodyPr rtlCol="0" anchor="ctr" wrap="square" lIns="274320" rIns="274320" tIns="228600" bIns="228600"/>
+          <a:bodyPr rtlCol="0" anchor="ctr" wrap="square" lIns="182880" rIns="182880" tIns="137160" bIns="137160"/>
           <a:lstStyle/>
           <a:p>
             <a:pPr algn="ctr">
-              <a:defRPr sz="2400" b="1">
+              <a:defRPr sz="1800" b="1">
                 <a:solidFill>
                   <a:srgbClr val="6366F1"/>
                 </a:solidFill>
@@ -5891,7 +5987,7 @@
           </a:p>
           <a:p>
             <a:pPr>
-              <a:defRPr sz="1600" b="1">
+              <a:defRPr sz="1300" b="1">
                 <a:solidFill>
                   <a:srgbClr val="FFFFFF"/>
                 </a:solidFill>
@@ -5905,9 +6001,9 @@
           <a:p>
             <a:pPr>
               <a:spcBef>
-                <a:spcPts val="800"/>
+                <a:spcPts val="300"/>
               </a:spcBef>
-              <a:defRPr sz="1200">
+              <a:defRPr sz="1050">
                 <a:solidFill>
                   <a:srgbClr val="CBD5E1"/>
                 </a:solidFill>
@@ -5915,7 +6011,7 @@
               </a:defRPr>
             </a:pPr>
             <a:r>
-              <a:t>Automated WhatsApp payment links and instant online settlement reduce unpaid credit and overdue accounts.</a:t>
+              <a:t>Automated WhatsApp payment links and instant settlement recover credit 40% faster.</a:t>
             </a:r>
           </a:p>
         </p:txBody>
@@ -5928,8 +6024,8 @@
         </p:nvSpPr>
         <p:spPr>
           <a:xfrm>
-            <a:off x="731520" y="4297680"/>
-            <a:ext cx="5120640" cy="2011680"/>
+            <a:off x="731520" y="4206240"/>
+            <a:ext cx="2926080" cy="2194560"/>
           </a:xfrm>
           <a:prstGeom prst="roundRect">
             <a:avLst/>
@@ -5958,11 +6054,11 @@
           </a:fontRef>
         </p:style>
         <p:txBody>
-          <a:bodyPr rtlCol="0" anchor="ctr" wrap="square" lIns="274320" rIns="274320" tIns="228600" bIns="228600"/>
+          <a:bodyPr rtlCol="0" anchor="ctr" wrap="square" lIns="182880" rIns="182880" tIns="137160" bIns="137160"/>
           <a:lstStyle/>
           <a:p>
             <a:pPr algn="ctr">
-              <a:defRPr sz="2400" b="1">
+              <a:defRPr sz="1800" b="1">
                 <a:solidFill>
                   <a:srgbClr val="06B6D4"/>
                 </a:solidFill>
@@ -5975,7 +6071,7 @@
           </a:p>
           <a:p>
             <a:pPr>
-              <a:defRPr sz="1600" b="1">
+              <a:defRPr sz="1300" b="1">
                 <a:solidFill>
                   <a:srgbClr val="FFFFFF"/>
                 </a:solidFill>
@@ -5989,9 +6085,9 @@
           <a:p>
             <a:pPr>
               <a:spcBef>
-                <a:spcPts val="800"/>
+                <a:spcPts val="300"/>
               </a:spcBef>
-              <a:defRPr sz="1200">
+              <a:defRPr sz="1050">
                 <a:solidFill>
                   <a:srgbClr val="CBD5E1"/>
                 </a:solidFill>
@@ -5999,7 +6095,7 @@
               </a:defRPr>
             </a:pPr>
             <a:r>
-              <a:t>Customers track their own packages on live GPS maps, eliminating endless 'Where is my parcel?' inquiries.</a:t>
+              <a:t>Customers track their own packages on live GPS maps, eliminating endless inquiries.</a:t>
             </a:r>
           </a:p>
         </p:txBody>
@@ -6012,8 +6108,8 @@
         </p:nvSpPr>
         <p:spPr>
           <a:xfrm>
-            <a:off x="6217920" y="4297680"/>
-            <a:ext cx="5120640" cy="2011680"/>
+            <a:off x="3840480" y="4206240"/>
+            <a:ext cx="2926080" cy="2194560"/>
           </a:xfrm>
           <a:prstGeom prst="roundRect">
             <a:avLst/>
@@ -6042,11 +6138,11 @@
           </a:fontRef>
         </p:style>
         <p:txBody>
-          <a:bodyPr rtlCol="0" anchor="ctr" wrap="square" lIns="274320" rIns="274320" tIns="228600" bIns="228600"/>
+          <a:bodyPr rtlCol="0" anchor="ctr" wrap="square" lIns="182880" rIns="182880" tIns="137160" bIns="137160"/>
           <a:lstStyle/>
           <a:p>
             <a:pPr algn="ctr">
-              <a:defRPr sz="2400" b="1">
+              <a:defRPr sz="1800" b="1">
                 <a:solidFill>
                   <a:srgbClr val="8B5CF6"/>
                 </a:solidFill>
@@ -6059,7 +6155,7 @@
           </a:p>
           <a:p>
             <a:pPr>
-              <a:defRPr sz="1600" b="1">
+              <a:defRPr sz="1300" b="1">
                 <a:solidFill>
                   <a:srgbClr val="FFFFFF"/>
                 </a:solidFill>
@@ -6073,9 +6169,9 @@
           <a:p>
             <a:pPr>
               <a:spcBef>
-                <a:spcPts val="800"/>
+                <a:spcPts val="300"/>
               </a:spcBef>
-              <a:defRPr sz="1200">
+              <a:defRPr sz="1050">
                 <a:solidFill>
                   <a:srgbClr val="CBD5E1"/>
                 </a:solidFill>
@@ -6083,11 +6179,35 @@
               </a:defRPr>
             </a:pPr>
             <a:r>
-              <a:t>Single-click GSTR-1 summaries, P&amp;L reports, and catalog exports make tax filing completely painless.</a:t>
-            </a:r>
-          </a:p>
-        </p:txBody>
-      </p:sp>
+              <a:t>Single-click GSTR-1 summaries, P&amp;L reports, and catalog exports make filing simple.</a:t>
+            </a:r>
+          </a:p>
+        </p:txBody>
+      </p:sp>
+      <p:pic>
+        <p:nvPicPr>
+          <p:cNvPr id="10" name="Picture 9" descr="inventory.png"/>
+          <p:cNvPicPr>
+            <a:picLocks noChangeAspect="1"/>
+          </p:cNvPicPr>
+          <p:nvPr/>
+        </p:nvPicPr>
+        <p:blipFill>
+          <a:blip r:embed="rId2"/>
+          <a:stretch>
+            <a:fillRect/>
+          </a:stretch>
+        </p:blipFill>
+        <p:spPr>
+          <a:xfrm>
+            <a:off x="7040880" y="1828800"/>
+            <a:ext cx="4389120" cy="2084832"/>
+          </a:xfrm>
+          <a:prstGeom prst="rect">
+            <a:avLst/>
+          </a:prstGeom>
+        </p:spPr>
+      </p:pic>
     </p:spTree>
   </p:cSld>
   <p:clrMapOvr>
@@ -6157,8 +6277,8 @@
         </p:nvSpPr>
         <p:spPr>
           <a:xfrm>
-            <a:off x="1645920" y="1097280"/>
-            <a:ext cx="8869680" cy="4754880"/>
+            <a:off x="1097280" y="914400"/>
+            <a:ext cx="9966960" cy="5029200"/>
           </a:xfrm>
           <a:prstGeom prst="roundRect">
             <a:avLst/>
@@ -6199,7 +6319,7 @@
               </a:defRPr>
             </a:pPr>
             <a:r>
-              <a:t>✨ CONCLUSION &amp; DEMO ✨</a:t>
+              <a:t>✨ CONCLUSION &amp; Q&amp;A ✨</a:t>
             </a:r>
           </a:p>
           <a:p>
@@ -6251,13 +6371,13 @@
             </a:r>
             <a:br/>
             <a:r>
-              <a:t>01 - Pranali Bhagat  |  06 - Hrutuja Champanerkar  |  31 - Mayur Pandav  |  37 - Mol Patil</a:t>
+              <a:t>01 - Pranali Bhagat   |   06 - Hrutuja Champanerkar   |   31 - Mayur Pandav   |   37 - Mol Patil</a:t>
             </a:r>
           </a:p>
           <a:p>
             <a:pPr algn="ctr">
               <a:spcBef>
-                <a:spcPts val="1600"/>
+                <a:spcPts val="1800"/>
               </a:spcBef>
               <a:defRPr sz="1200">
                 <a:solidFill>

</xml_diff>